<commit_message>
week 11 lecture 2
</commit_message>
<xml_diff>
--- a/lectures/week11/lecture1/slides/week11_lecture1.pptx
+++ b/lectures/week11/lecture1/slides/week11_lecture1.pptx
@@ -209,7 +209,7 @@
           <a:p>
             <a:fld id="{125D7D83-D401-9A49-861D-A02E2788C764}" type="datetimeFigureOut">
               <a:rPr lang="en-US" smtClean="0"/>
-              <a:t>3/22/2026</a:t>
+              <a:t>3/23/2026</a:t>
             </a:fld>
             <a:endParaRPr lang="en-US"/>
           </a:p>
@@ -5176,126 +5176,6 @@
   <p:clrMapOvr>
     <a:masterClrMapping/>
   </p:clrMapOvr>
-  <p:timing>
-    <p:tnLst>
-      <p:par>
-        <p:cTn id="1" dur="indefinite" restart="never" nodeType="tmRoot">
-          <p:childTnLst>
-            <p:seq concurrent="1" nextAc="seek">
-              <p:cTn id="2" dur="indefinite" nodeType="mainSeq">
-                <p:childTnLst>
-                  <p:par>
-                    <p:cTn id="3" fill="hold">
-                      <p:stCondLst>
-                        <p:cond delay="indefinite"/>
-                      </p:stCondLst>
-                      <p:childTnLst>
-                        <p:par>
-                          <p:cTn id="4" fill="hold">
-                            <p:stCondLst>
-                              <p:cond delay="0"/>
-                            </p:stCondLst>
-                            <p:childTnLst>
-                              <p:par>
-                                <p:cTn id="5" presetID="1" presetClass="entr" presetSubtype="0" fill="hold" nodeType="clickEffect">
-                                  <p:stCondLst>
-                                    <p:cond delay="0"/>
-                                  </p:stCondLst>
-                                  <p:childTnLst>
-                                    <p:set>
-                                      <p:cBhvr>
-                                        <p:cTn id="6" dur="1" fill="hold">
-                                          <p:stCondLst>
-                                            <p:cond delay="0"/>
-                                          </p:stCondLst>
-                                        </p:cTn>
-                                        <p:tgtEl>
-                                          <p:spTgt spid="10"/>
-                                        </p:tgtEl>
-                                        <p:attrNameLst>
-                                          <p:attrName>style.visibility</p:attrName>
-                                        </p:attrNameLst>
-                                      </p:cBhvr>
-                                      <p:to>
-                                        <p:strVal val="visible"/>
-                                      </p:to>
-                                    </p:set>
-                                  </p:childTnLst>
-                                </p:cTn>
-                              </p:par>
-                            </p:childTnLst>
-                          </p:cTn>
-                        </p:par>
-                      </p:childTnLst>
-                    </p:cTn>
-                  </p:par>
-                  <p:par>
-                    <p:cTn id="7" fill="hold">
-                      <p:stCondLst>
-                        <p:cond delay="indefinite"/>
-                      </p:stCondLst>
-                      <p:childTnLst>
-                        <p:par>
-                          <p:cTn id="8" fill="hold">
-                            <p:stCondLst>
-                              <p:cond delay="0"/>
-                            </p:stCondLst>
-                            <p:childTnLst>
-                              <p:par>
-                                <p:cTn id="9" presetID="1" presetClass="entr" presetSubtype="0" fill="hold" nodeType="clickEffect">
-                                  <p:stCondLst>
-                                    <p:cond delay="0"/>
-                                  </p:stCondLst>
-                                  <p:childTnLst>
-                                    <p:set>
-                                      <p:cBhvr>
-                                        <p:cTn id="10" dur="1" fill="hold">
-                                          <p:stCondLst>
-                                            <p:cond delay="0"/>
-                                          </p:stCondLst>
-                                        </p:cTn>
-                                        <p:tgtEl>
-                                          <p:spTgt spid="14"/>
-                                        </p:tgtEl>
-                                        <p:attrNameLst>
-                                          <p:attrName>style.visibility</p:attrName>
-                                        </p:attrNameLst>
-                                      </p:cBhvr>
-                                      <p:to>
-                                        <p:strVal val="visible"/>
-                                      </p:to>
-                                    </p:set>
-                                  </p:childTnLst>
-                                </p:cTn>
-                              </p:par>
-                            </p:childTnLst>
-                          </p:cTn>
-                        </p:par>
-                      </p:childTnLst>
-                    </p:cTn>
-                  </p:par>
-                </p:childTnLst>
-              </p:cTn>
-              <p:prevCondLst>
-                <p:cond evt="onPrev" delay="0">
-                  <p:tgtEl>
-                    <p:sldTgt/>
-                  </p:tgtEl>
-                </p:cond>
-              </p:prevCondLst>
-              <p:nextCondLst>
-                <p:cond evt="onNext" delay="0">
-                  <p:tgtEl>
-                    <p:sldTgt/>
-                  </p:tgtEl>
-                </p:cond>
-              </p:nextCondLst>
-            </p:seq>
-          </p:childTnLst>
-        </p:cTn>
-      </p:par>
-    </p:tnLst>
-  </p:timing>
 </p:sld>
 </file>
 
@@ -7987,7 +7867,7 @@
         <p:spPr>
           <a:xfrm>
             <a:off x="339436" y="1714788"/>
-            <a:ext cx="10674928" cy="4835479"/>
+            <a:ext cx="9123616" cy="4835479"/>
           </a:xfrm>
         </p:spPr>
         <p:txBody>
@@ -8069,7 +7949,7 @@
         <p:spPr>
           <a:xfrm>
             <a:off x="572962" y="2614348"/>
-            <a:ext cx="9318914" cy="2554545"/>
+            <a:ext cx="9318914" cy="2246769"/>
           </a:xfrm>
           <a:prstGeom prst="rect">
             <a:avLst/>
@@ -8123,22 +8003,7 @@
                 <a:latin typeface="Courier New"/>
                 <a:cs typeface="Courier New"/>
               </a:rPr>
-              <a:t>"""A class that represents and manipulates 2D points"""</a:t>
-            </a:r>
-          </a:p>
-          <a:p>
-            <a:pPr lvl="0">
-              <a:defRPr/>
-            </a:pPr>
-            <a:r>
-              <a:rPr lang="en-CA" sz="2000" b="1" spc="-5" dirty="0">
-                <a:solidFill>
-                  <a:srgbClr val="00FF00"/>
-                </a:solidFill>
-                <a:latin typeface="Courier New"/>
-                <a:cs typeface="Courier New"/>
-              </a:rPr>
-              <a:t>    def __</a:t>
+              <a:t>def __</a:t>
             </a:r>
             <a:r>
               <a:rPr lang="en-CA" sz="2000" b="1" spc="-5" dirty="0" err="1">
@@ -8284,7 +8149,7 @@
         </p:nvSpPr>
         <p:spPr>
           <a:xfrm>
-            <a:off x="4371515" y="5645844"/>
+            <a:off x="4371515" y="5433196"/>
             <a:ext cx="6412099" cy="929870"/>
           </a:xfrm>
           <a:prstGeom prst="rect">
@@ -9442,7 +9307,7 @@
         </p:nvSpPr>
         <p:spPr>
           <a:xfrm>
-            <a:off x="932419" y="4267685"/>
+            <a:off x="932419" y="3962889"/>
             <a:ext cx="9123616" cy="1061743"/>
           </a:xfrm>
           <a:prstGeom prst="frame">
@@ -9498,7 +9363,7 @@
         </p:nvSpPr>
         <p:spPr>
           <a:xfrm>
-            <a:off x="579268" y="5656890"/>
+            <a:off x="579268" y="5444242"/>
             <a:ext cx="2954655" cy="1015663"/>
           </a:xfrm>
           <a:prstGeom prst="rect">
@@ -9565,6 +9430,236 @@
                 <a:cs typeface="Courier New" panose="02070309020205020404" pitchFamily="49" charset="0"/>
               </a:rPr>
               <a:t>'(3,4)'</a:t>
+            </a:r>
+          </a:p>
+        </p:txBody>
+      </p:sp>
+      <p:sp>
+        <p:nvSpPr>
+          <p:cNvPr id="6" name="TextBox 5">
+            <a:extLst>
+              <a:ext uri="{FF2B5EF4-FFF2-40B4-BE49-F238E27FC236}">
+                <a16:creationId xmlns:a16="http://schemas.microsoft.com/office/drawing/2014/main" id="{C6F6A7F1-316C-9CC1-7F7E-59C643A5C7A5}"/>
+              </a:ext>
+            </a:extLst>
+          </p:cNvPr>
+          <p:cNvSpPr txBox="1"/>
+          <p:nvPr/>
+        </p:nvSpPr>
+        <p:spPr>
+          <a:xfrm>
+            <a:off x="9966251" y="644998"/>
+            <a:ext cx="2046768" cy="1754326"/>
+          </a:xfrm>
+          <a:prstGeom prst="rect">
+            <a:avLst/>
+          </a:prstGeom>
+          <a:noFill/>
+        </p:spPr>
+        <p:txBody>
+          <a:bodyPr wrap="square" rtlCol="0">
+            <a:spAutoFit/>
+          </a:bodyPr>
+          <a:lstStyle/>
+          <a:p>
+            <a:r>
+              <a:rPr lang="en-CA" b="1" dirty="0">
+                <a:solidFill>
+                  <a:srgbClr val="00FF00"/>
+                </a:solidFill>
+              </a:rPr>
+              <a:t>Special Methods</a:t>
+            </a:r>
+          </a:p>
+          <a:p>
+            <a:r>
+              <a:rPr lang="en-CA" b="1" dirty="0">
+                <a:solidFill>
+                  <a:srgbClr val="00FF00"/>
+                </a:solidFill>
+              </a:rPr>
+              <a:t>Magic Methods</a:t>
+            </a:r>
+          </a:p>
+          <a:p>
+            <a:endParaRPr lang="en-US" dirty="0">
+              <a:solidFill>
+                <a:srgbClr val="FFFFFF"/>
+              </a:solidFill>
+            </a:endParaRPr>
+          </a:p>
+          <a:p>
+            <a:r>
+              <a:rPr lang="en-US" dirty="0">
+                <a:solidFill>
+                  <a:srgbClr val="FFFFFF"/>
+                </a:solidFill>
+              </a:rPr>
+              <a:t>These are part of Python</a:t>
+            </a:r>
+            <a:r>
+              <a:rPr lang="en-US" dirty="0">
+                <a:solidFill>
+                  <a:srgbClr val="CC99FF"/>
+                </a:solidFill>
+              </a:rPr>
+              <a:t>’</a:t>
+            </a:r>
+            <a:r>
+              <a:rPr lang="en-US" dirty="0">
+                <a:solidFill>
+                  <a:srgbClr val="FFFFFF"/>
+                </a:solidFill>
+              </a:rPr>
+              <a:t>s special object protocol</a:t>
+            </a:r>
+            <a:r>
+              <a:rPr lang="en-US" dirty="0">
+                <a:solidFill>
+                  <a:srgbClr val="CC99FF"/>
+                </a:solidFill>
+              </a:rPr>
+              <a:t>.</a:t>
+            </a:r>
+            <a:endParaRPr lang="en-CA" dirty="0">
+              <a:solidFill>
+                <a:srgbClr val="CC99FF"/>
+              </a:solidFill>
+            </a:endParaRPr>
+          </a:p>
+        </p:txBody>
+      </p:sp>
+      <p:sp>
+        <p:nvSpPr>
+          <p:cNvPr id="10" name="TextBox 9">
+            <a:extLst>
+              <a:ext uri="{FF2B5EF4-FFF2-40B4-BE49-F238E27FC236}">
+                <a16:creationId xmlns:a16="http://schemas.microsoft.com/office/drawing/2014/main" id="{9ABDA52E-6DA2-E09D-E27B-6DE3D5C04D9C}"/>
+              </a:ext>
+            </a:extLst>
+          </p:cNvPr>
+          <p:cNvSpPr txBox="1"/>
+          <p:nvPr/>
+        </p:nvSpPr>
+        <p:spPr>
+          <a:xfrm>
+            <a:off x="6743473" y="2642699"/>
+            <a:ext cx="5109091" cy="1015663"/>
+          </a:xfrm>
+          <a:prstGeom prst="rect">
+            <a:avLst/>
+          </a:prstGeom>
+          <a:noFill/>
+        </p:spPr>
+        <p:txBody>
+          <a:bodyPr wrap="none" rtlCol="0">
+            <a:spAutoFit/>
+          </a:bodyPr>
+          <a:lstStyle/>
+          <a:p>
+            <a:r>
+              <a:rPr lang="en-CA" sz="2000" b="1" dirty="0" err="1">
+                <a:solidFill>
+                  <a:srgbClr val="00FF00"/>
+                </a:solidFill>
+                <a:latin typeface="Courier New" panose="02070309020205020404" pitchFamily="49" charset="0"/>
+                <a:cs typeface="Courier New" panose="02070309020205020404" pitchFamily="49" charset="0"/>
+              </a:rPr>
+              <a:t>len</a:t>
+            </a:r>
+            <a:r>
+              <a:rPr lang="en-CA" sz="2000" b="1" dirty="0">
+                <a:solidFill>
+                  <a:srgbClr val="00FF00"/>
+                </a:solidFill>
+                <a:latin typeface="Courier New" panose="02070309020205020404" pitchFamily="49" charset="0"/>
+                <a:cs typeface="Courier New" panose="02070309020205020404" pitchFamily="49" charset="0"/>
+              </a:rPr>
+              <a:t>(x) → x.__</a:t>
+            </a:r>
+            <a:r>
+              <a:rPr lang="en-CA" sz="2000" b="1" dirty="0" err="1">
+                <a:solidFill>
+                  <a:srgbClr val="00FF00"/>
+                </a:solidFill>
+                <a:latin typeface="Courier New" panose="02070309020205020404" pitchFamily="49" charset="0"/>
+                <a:cs typeface="Courier New" panose="02070309020205020404" pitchFamily="49" charset="0"/>
+              </a:rPr>
+              <a:t>len</a:t>
+            </a:r>
+            <a:r>
+              <a:rPr lang="en-CA" sz="2000" b="1" dirty="0">
+                <a:solidFill>
+                  <a:srgbClr val="00FF00"/>
+                </a:solidFill>
+                <a:latin typeface="Courier New" panose="02070309020205020404" pitchFamily="49" charset="0"/>
+                <a:cs typeface="Courier New" panose="02070309020205020404" pitchFamily="49" charset="0"/>
+              </a:rPr>
+              <a:t>__()</a:t>
+            </a:r>
+          </a:p>
+          <a:p>
+            <a:r>
+              <a:rPr lang="en-CA" sz="2000" b="1" dirty="0">
+                <a:solidFill>
+                  <a:srgbClr val="00FF00"/>
+                </a:solidFill>
+                <a:latin typeface="Courier New" panose="02070309020205020404" pitchFamily="49" charset="0"/>
+                <a:cs typeface="Courier New" panose="02070309020205020404" pitchFamily="49" charset="0"/>
+              </a:rPr>
+              <a:t>print(x) or str(x) → </a:t>
+            </a:r>
+            <a:r>
+              <a:rPr lang="en-CA" sz="2000" b="1" dirty="0" err="1">
+                <a:solidFill>
+                  <a:srgbClr val="00FF00"/>
+                </a:solidFill>
+                <a:latin typeface="Courier New" panose="02070309020205020404" pitchFamily="49" charset="0"/>
+                <a:cs typeface="Courier New" panose="02070309020205020404" pitchFamily="49" charset="0"/>
+              </a:rPr>
+              <a:t>x.__str</a:t>
+            </a:r>
+            <a:r>
+              <a:rPr lang="en-CA" sz="2000" b="1" dirty="0">
+                <a:solidFill>
+                  <a:srgbClr val="00FF00"/>
+                </a:solidFill>
+                <a:latin typeface="Courier New" panose="02070309020205020404" pitchFamily="49" charset="0"/>
+                <a:cs typeface="Courier New" panose="02070309020205020404" pitchFamily="49" charset="0"/>
+              </a:rPr>
+              <a:t>__()</a:t>
+            </a:r>
+          </a:p>
+          <a:p>
+            <a:r>
+              <a:rPr lang="en-CA" sz="2000" b="1" dirty="0">
+                <a:solidFill>
+                  <a:srgbClr val="00FF00"/>
+                </a:solidFill>
+                <a:latin typeface="Courier New" panose="02070309020205020404" pitchFamily="49" charset="0"/>
+                <a:cs typeface="Courier New" panose="02070309020205020404" pitchFamily="49" charset="0"/>
+              </a:rPr>
+              <a:t>bool(x) → </a:t>
+            </a:r>
+            <a:r>
+              <a:rPr lang="en-CA" sz="2000" b="1" dirty="0" err="1">
+                <a:solidFill>
+                  <a:srgbClr val="00FF00"/>
+                </a:solidFill>
+                <a:latin typeface="Courier New" panose="02070309020205020404" pitchFamily="49" charset="0"/>
+                <a:cs typeface="Courier New" panose="02070309020205020404" pitchFamily="49" charset="0"/>
+              </a:rPr>
+              <a:t>x.__bool</a:t>
+            </a:r>
+            <a:r>
+              <a:rPr lang="en-CA" sz="2000" b="1" dirty="0">
+                <a:solidFill>
+                  <a:srgbClr val="00FF00"/>
+                </a:solidFill>
+                <a:latin typeface="Courier New" panose="02070309020205020404" pitchFamily="49" charset="0"/>
+                <a:cs typeface="Courier New" panose="02070309020205020404" pitchFamily="49" charset="0"/>
+              </a:rPr>
+              <a:t>__()</a:t>
             </a:r>
           </a:p>
         </p:txBody>

</xml_diff>